<commit_message>
Update Azure to AWS Migration presentation slides
</commit_message>
<xml_diff>
--- a/presentation/Azure-to-AWS-Migration.pptx
+++ b/presentation/Azure-to-AWS-Migration.pptx
@@ -5,7 +5,7 @@
     <p:sldMasterId id="2147483648" r:id="rId1"/>
   </p:sldMasterIdLst>
   <p:notesMasterIdLst>
-    <p:notesMasterId r:id="rId16"/>
+    <p:notesMasterId r:id="rId17"/>
   </p:notesMasterIdLst>
   <p:sldIdLst>
     <p:sldId id="256" r:id="rId2"/>
@@ -22,6 +22,7 @@
     <p:sldId id="267" r:id="rId13"/>
     <p:sldId id="268" r:id="rId14"/>
     <p:sldId id="270" r:id="rId15"/>
+    <p:sldId id="271" r:id="rId16"/>
   </p:sldIdLst>
   <p:sldSz cx="12192000" cy="6858000"/>
   <p:notesSz cx="6858000" cy="9144000"/>
@@ -309,6 +310,7 @@
           <a:lstStyle/>
           <a:p>
             <a:r>
+              <a:rPr dirty="0"/>
               <a:t>Welcome. Today I'm presenting an agentic pipeline that migrates Azure Bicep infrastructure-as-code to AWS CloudFormation. The key idea: wrap deterministic code and human approval around a single LLM reasoning step, so migrations are safe and auditable. I'll cover the business problem, how we're different, the architecture, safety, and results.</a:t>
             </a:r>
           </a:p>
@@ -799,7 +801,16 @@
           <a:lstStyle/>
           <a:p>
             <a:r>
-              <a:t>Technically, rewriting Bicep into CloudFormation by hand is slow and error-prone, leaves no audit trail, and can introduce security gaps. You might ask: why not just have an LLM write the template? Because one-shot generation is unreliable and unauditable — it can hallucinate syntax and leak secrets with no record of its decisions. So we take a structured approach instead.</a:t>
+              <a:rPr dirty="0"/>
+              <a:t>Technically, rewriting Bicep into CloudFormation by hand is slow and error-prone, leaves no audit trail, and can introduce security gaps. You might ask: why not just have an LLM write the template? Because one-shot generation is unreliable and </a:t>
+            </a:r>
+            <a:r>
+              <a:rPr dirty="0" err="1"/>
+              <a:t>unauditable</a:t>
+            </a:r>
+            <a:r>
+              <a:rPr dirty="0"/>
+              <a:t> — it can hallucinate syntax and leak secrets with no record of its decisions. So we take a structured approach instead.</a:t>
             </a:r>
           </a:p>
         </p:txBody>
@@ -9775,6 +9786,77 @@
         </p:txBody>
       </p:sp>
     </p:spTree>
+  </p:cSld>
+  <p:clrMapOvr>
+    <a:masterClrMapping/>
+  </p:clrMapOvr>
+</p:sld>
+</file>
+
+<file path=ppt/slides/slide15.xml><?xml version="1.0" encoding="utf-8"?>
+<p:sld xmlns:a="http://schemas.openxmlformats.org/drawingml/2006/main" xmlns:r="http://schemas.openxmlformats.org/officeDocument/2006/relationships" xmlns:p="http://schemas.openxmlformats.org/presentationml/2006/main">
+  <p:cSld>
+    <p:spTree>
+      <p:nvGrpSpPr>
+        <p:cNvPr id="1" name=""/>
+        <p:cNvGrpSpPr/>
+        <p:nvPr/>
+      </p:nvGrpSpPr>
+      <p:grpSpPr>
+        <a:xfrm>
+          <a:off x="0" y="0"/>
+          <a:ext cx="0" cy="0"/>
+          <a:chOff x="0" y="0"/>
+          <a:chExt cx="0" cy="0"/>
+        </a:xfrm>
+      </p:grpSpPr>
+      <p:sp>
+        <p:nvSpPr>
+          <p:cNvPr id="2" name="TextBox 1">
+            <a:extLst>
+              <a:ext uri="{FF2B5EF4-FFF2-40B4-BE49-F238E27FC236}">
+                <a16:creationId xmlns:a16="http://schemas.microsoft.com/office/drawing/2014/main" id="{18BBDE80-99EE-E627-3646-6684481AE3F9}"/>
+              </a:ext>
+            </a:extLst>
+          </p:cNvPr>
+          <p:cNvSpPr txBox="1"/>
+          <p:nvPr/>
+        </p:nvSpPr>
+        <p:spPr>
+          <a:xfrm>
+            <a:off x="2911365" y="2676297"/>
+            <a:ext cx="6369269" cy="1015663"/>
+          </a:xfrm>
+          <a:prstGeom prst="rect">
+            <a:avLst/>
+          </a:prstGeom>
+          <a:noFill/>
+        </p:spPr>
+        <p:txBody>
+          <a:bodyPr wrap="square" rtlCol="0">
+            <a:spAutoFit/>
+          </a:bodyPr>
+          <a:lstStyle/>
+          <a:p>
+            <a:pPr algn="ctr"/>
+            <a:r>
+              <a:rPr lang="en-US" sz="6000" dirty="0">
+                <a:latin typeface="Arial Black" panose="020B0A04020102020204" pitchFamily="34" charset="0"/>
+              </a:rPr>
+              <a:t>Demo</a:t>
+            </a:r>
+            <a:endParaRPr lang="en-IN" sz="6000" dirty="0">
+              <a:latin typeface="Arial Black" panose="020B0A04020102020204" pitchFamily="34" charset="0"/>
+            </a:endParaRPr>
+          </a:p>
+        </p:txBody>
+      </p:sp>
+    </p:spTree>
+    <p:extLst>
+      <p:ext uri="{BB962C8B-B14F-4D97-AF65-F5344CB8AC3E}">
+        <p14:creationId xmlns:p14="http://schemas.microsoft.com/office/powerpoint/2010/main" val="2709054890"/>
+      </p:ext>
+    </p:extLst>
   </p:cSld>
   <p:clrMapOvr>
     <a:masterClrMapping/>

</xml_diff>